<commit_message>
Praesentation aktualisiert: Memory-Demo, VS Code Hinweis, Capstone-Folie, keine Gedankenstriche
</commit_message>
<xml_diff>
--- a/Claude_Code_Pitch.pptx
+++ b/Claude_Code_Pitch.pptx
@@ -3317,12 +3317,12 @@
                 <a:latin typeface="Courier New"/>
               </a:rPr>
               <a:t>$ claude
-&gt; Analysiere dieses Projekt und
-  schreibe Unit-Tests für app.py
-  Reading files...
-  Planning 4 steps...
-  Writing test_app.py ✓
-  Running pytest ✓  (12 passed)</a:t>
+&gt; Lies content.json und erstelle daraus
+  ein spielbares Memory-Spiel als memory.html
+  Reading: content.json ...
+  Planning: card layout, flip animation, scoring
+  Writing: memory.html ✓
+  Done. Open memory.html to play!</a:t>
             </a:r>
           </a:p>
         </p:txBody>
@@ -4953,7 +4953,7 @@
                 </a:solidFill>
                 <a:latin typeface="Calibri"/>
               </a:rPr>
-              <a:t>VS Code + JetBrains Plugin</a:t>
+              <a:t>VS Code (taeglicher Einsatz) + JetBrains</a:t>
             </a:r>
           </a:p>
         </p:txBody>
@@ -5066,7 +5066,7 @@
                 </a:solidFill>
                 <a:latin typeface="Calibri"/>
               </a:rPr>
-              <a:t>Läuft via Anthropic API</a:t>
+              <a:t>Laeuft via Anthropic API</a:t>
             </a:r>
           </a:p>
         </p:txBody>
@@ -6354,7 +6354,7 @@
                 </a:solidFill>
                 <a:latin typeface="Calibri"/>
               </a:rPr>
-              <a:t>Proprietäre Modelle — kein Ollama / LM Studio</a:t>
+              <a:t>Proprietaere Modelle, kein Ollama / LM Studio</a:t>
             </a:r>
           </a:p>
         </p:txBody>
@@ -7545,7 +7545,7 @@
                 </a:solidFill>
                 <a:latin typeface="Calibri"/>
               </a:rPr>
-              <a:t>Kein dediziertes Student-Pricing — API Pay-per-use ist für Studierende am günstigsten.</a:t>
+              <a:t>Kein dediziertes Student-Pricing. API Pay-per-use ist fuer Studierende am guenstigsten.</a:t>
             </a:r>
           </a:p>
         </p:txBody>
@@ -7937,7 +7937,7 @@
                 </a:solidFill>
                 <a:latin typeface="Calibri"/>
               </a:rPr>
-              <a:t>Proprietär · Closed Source</a:t>
+              <a:t>Proprietaer, Closed Source</a:t>
             </a:r>
           </a:p>
         </p:txBody>
@@ -8085,7 +8085,7 @@
                 </a:solidFill>
                 <a:latin typeface="Calibri"/>
               </a:rPr>
-              <a:t>Frei via npm installierbar · nicht open source</a:t>
+              <a:t>Frei via npm installierbar, nicht open source</a:t>
             </a:r>
           </a:p>
         </p:txBody>
@@ -8233,7 +8233,7 @@
                 </a:solidFill>
                 <a:latin typeface="Calibri"/>
               </a:rPr>
-              <a:t>Open Source auf GitHub (Python, TypeScript …)</a:t>
+              <a:t>Open Source auf GitHub (Python, TypeScript ...)</a:t>
             </a:r>
           </a:p>
         </p:txBody>
@@ -8381,7 +8381,7 @@
                 </a:solidFill>
                 <a:latin typeface="Calibri"/>
               </a:rPr>
-              <a:t>Model Context Protocol — Open Standard</a:t>
+              <a:t>Model Context Protocol, offener Standard</a:t>
             </a:r>
           </a:p>
         </p:txBody>
@@ -8459,7 +8459,7 @@
                 </a:solidFill>
                 <a:latin typeface="Calibri"/>
               </a:rPr>
-              <a:t>Fazit: Claude Code ist kein Open-Source-Projekt — aber der CLI-Client und SDKs sind frei zugänglich.</a:t>
+              <a:t>Fazit: Claude Code ist kein Open-Source-Projekt, aber CLI-Client und SDKs sind frei zugaenglich.</a:t>
             </a:r>
           </a:p>
         </p:txBody>
@@ -8867,7 +8867,7 @@
                 </a:solidFill>
                 <a:latin typeface="Courier New"/>
               </a:rPr>
-              <a:t>$ claude</a:t>
+              <a:t>$ cd ~/Desktop/claude-code-demo &amp;&amp; claude</a:t>
             </a:r>
           </a:p>
         </p:txBody>
@@ -8937,7 +8937,7 @@
                 </a:solidFill>
                 <a:latin typeface="Courier New"/>
               </a:rPr>
-              <a:t>&gt; Schreibe Unit-Tests für alle Funktionen in app.py</a:t>
+              <a:t>&gt; Lies content.json und erstelle ein Memory-Spiel als memory.html</a:t>
             </a:r>
           </a:p>
         </p:txBody>
@@ -9007,7 +9007,7 @@
                 </a:solidFill>
                 <a:latin typeface="Courier New"/>
               </a:rPr>
-              <a:t>  ✓ Reading: app.py (142 lines)</a:t>
+              <a:t>  Reading: content.json (8 Begriffspaare)</a:t>
             </a:r>
           </a:p>
         </p:txBody>
@@ -9042,7 +9042,7 @@
                 </a:solidFill>
                 <a:latin typeface="Courier New"/>
               </a:rPr>
-              <a:t>  ✓ Planning: 3 test functions identified</a:t>
+              <a:t>  Planning: 4x4 Grid, Flip-Animation, Scoring ...</a:t>
             </a:r>
           </a:p>
         </p:txBody>
@@ -9077,7 +9077,7 @@
                 </a:solidFill>
                 <a:latin typeface="Courier New"/>
               </a:rPr>
-              <a:t>  ✓ Writing: test_app.py</a:t>
+              <a:t>  Writing: memory.html</a:t>
             </a:r>
           </a:p>
         </p:txBody>
@@ -9112,7 +9112,7 @@
                 </a:solidFill>
                 <a:latin typeface="Courier New"/>
               </a:rPr>
-              <a:t>  ✓ Running: pytest → 3 passed in 0.4s</a:t>
+              <a:t>  Done!  open memory.html</a:t>
             </a:r>
           </a:p>
         </p:txBody>
@@ -9182,7 +9182,7 @@
                 </a:solidFill>
                 <a:latin typeface="Courier New"/>
               </a:rPr>
-              <a:t>  Done. Shall I also add edge-case tests? [y/n]</a:t>
+              <a:t>  Soll ich auch eine Quiz-Variante erstellen? [y/n]</a:t>
             </a:r>
           </a:p>
         </p:txBody>
@@ -9781,7 +9781,7 @@
                 </a:solidFill>
                 <a:latin typeface="Calibri"/>
               </a:rPr>
-              <a:t>Plant und führt mehrstufige Software-Tasks eigenständig aus</a:t>
+              <a:t>Plant und fuehrt mehrstufige Software-Tasks eigenstaendig aus</a:t>
             </a:r>
           </a:p>
         </p:txBody>
@@ -9937,7 +9937,7 @@
                 </a:solidFill>
                 <a:latin typeface="Calibri"/>
               </a:rPr>
-              <a:t>Claude Sonnet 4.6 empfohlen — stark &amp; kosteneffizient</a:t>
+              <a:t>Claude Sonnet 4.6 empfohlen: schnell, stark, kosteneffizient</a:t>
             </a:r>
           </a:p>
         </p:txBody>
@@ -10093,7 +10093,7 @@
                 </a:solidFill>
                 <a:latin typeface="Calibri"/>
               </a:rPr>
-              <a:t>macOS, Linux, Windows · CLI + IDE Extensions</a:t>
+              <a:t>macOS, Linux, Windows. CLI und VS Code Extension</a:t>
             </a:r>
           </a:p>
         </p:txBody>
@@ -10249,7 +10249,7 @@
                 </a:solidFill>
                 <a:latin typeface="Calibri"/>
               </a:rPr>
-              <a:t>API Pay-per-use ideal für Studierende (~$5 Einstieg)</a:t>
+              <a:t>API Pay-per-use ideal fuer Studierende (ab ca. $5)</a:t>
             </a:r>
           </a:p>
         </p:txBody>
@@ -10405,7 +10405,7 @@
                 </a:solidFill>
                 <a:latin typeface="Calibri"/>
               </a:rPr>
-              <a:t>Nicht vollständig — CLI frei, Modelle proprietär</a:t>
+              <a:t>Nicht vollstaendig: CLI frei zugaenglich, Modelle proprietaer</a:t>
             </a:r>
           </a:p>
         </p:txBody>
@@ -10418,8 +10418,51 @@
         </p:nvSpPr>
         <p:spPr>
           <a:xfrm>
-            <a:off x="457200" y="5029200"/>
-            <a:ext cx="11247120" cy="914400"/>
+            <a:off x="457200" y="4846320"/>
+            <a:ext cx="11247120" cy="658368"/>
+          </a:xfrm>
+          <a:prstGeom prst="rect">
+            <a:avLst/>
+          </a:prstGeom>
+          <a:solidFill>
+            <a:srgbClr val="FFFFFF"/>
+          </a:solidFill>
+          <a:ln>
+            <a:noFill/>
+          </a:ln>
+        </p:spPr>
+        <p:style>
+          <a:lnRef idx="1">
+            <a:schemeClr val="accent1"/>
+          </a:lnRef>
+          <a:fillRef idx="3">
+            <a:schemeClr val="accent1"/>
+          </a:fillRef>
+          <a:effectRef idx="2">
+            <a:schemeClr val="accent1"/>
+          </a:effectRef>
+          <a:fontRef idx="minor">
+            <a:schemeClr val="lt1"/>
+          </a:fontRef>
+        </p:style>
+        <p:txBody>
+          <a:bodyPr rtlCol="0" anchor="ctr"/>
+          <a:lstStyle/>
+          <a:p>
+            <a:pPr algn="ctr"/>
+          </a:p>
+        </p:txBody>
+      </p:sp>
+      <p:sp>
+        <p:nvSpPr>
+          <p:cNvPr id="26" name="Rectangle 25"/>
+          <p:cNvSpPr/>
+          <p:nvPr/>
+        </p:nvSpPr>
+        <p:spPr>
+          <a:xfrm>
+            <a:off x="457200" y="4846320"/>
+            <a:ext cx="109728" cy="658368"/>
           </a:xfrm>
           <a:prstGeom prst="rect">
             <a:avLst/>
@@ -10455,49 +10498,84 @@
       </p:sp>
       <p:sp>
         <p:nvSpPr>
-          <p:cNvPr id="26" name="TextBox 25"/>
-          <p:cNvSpPr txBox="1"/>
-          <p:nvPr/>
-        </p:nvSpPr>
-        <p:spPr>
-          <a:xfrm>
-            <a:off x="640080" y="5120640"/>
-            <a:ext cx="10972800" cy="731520"/>
-          </a:xfrm>
-          <a:prstGeom prst="rect">
-            <a:avLst/>
-          </a:prstGeom>
-          <a:noFill/>
-        </p:spPr>
-        <p:txBody>
-          <a:bodyPr wrap="square">
-            <a:spAutoFit/>
-          </a:bodyPr>
-          <a:lstStyle/>
-          <a:p>
-            <a:pPr algn="ctr"/>
-            <a:r>
-              <a:rPr sz="2000" b="1">
+          <p:cNvPr id="27" name="TextBox 26"/>
+          <p:cNvSpPr txBox="1"/>
+          <p:nvPr/>
+        </p:nvSpPr>
+        <p:spPr>
+          <a:xfrm>
+            <a:off x="685800" y="4973320"/>
+            <a:ext cx="2286000" cy="502920"/>
+          </a:xfrm>
+          <a:prstGeom prst="rect">
+            <a:avLst/>
+          </a:prstGeom>
+          <a:noFill/>
+        </p:spPr>
+        <p:txBody>
+          <a:bodyPr wrap="square">
+            <a:spAutoFit/>
+          </a:bodyPr>
+          <a:lstStyle/>
+          <a:p>
+            <a:pPr algn="l"/>
+            <a:r>
+              <a:rPr sz="1600" b="1">
                 <a:solidFill>
                   <a:srgbClr val="000000"/>
                 </a:solidFill>
                 <a:latin typeface="Calibri"/>
               </a:rPr>
-              <a:t>Fragen?   —   Ich kann Claude Code direkt hier im Terminal demonstrieren.</a:t>
-            </a:r>
-          </a:p>
-        </p:txBody>
-      </p:sp>
-      <p:sp>
-        <p:nvSpPr>
-          <p:cNvPr id="27" name="Rectangle 26"/>
+              <a:t>Capstone</a:t>
+            </a:r>
+          </a:p>
+        </p:txBody>
+      </p:sp>
+      <p:sp>
+        <p:nvSpPr>
+          <p:cNvPr id="28" name="TextBox 27"/>
+          <p:cNvSpPr txBox="1"/>
+          <p:nvPr/>
+        </p:nvSpPr>
+        <p:spPr>
+          <a:xfrm>
+            <a:off x="3108960" y="4973320"/>
+            <a:ext cx="8503920" cy="502920"/>
+          </a:xfrm>
+          <a:prstGeom prst="rect">
+            <a:avLst/>
+          </a:prstGeom>
+          <a:noFill/>
+        </p:spPr>
+        <p:txBody>
+          <a:bodyPr wrap="square">
+            <a:spAutoFit/>
+          </a:bodyPr>
+          <a:lstStyle/>
+          <a:p>
+            <a:pPr algn="l"/>
+            <a:r>
+              <a:rPr sz="1600" b="0">
+                <a:solidFill>
+                  <a:srgbClr val="333333"/>
+                </a:solidFill>
+                <a:latin typeface="Calibri"/>
+              </a:rPr>
+              <a:t>Wir nutzen Claude Code um unsere Lernplattform zu bauen</a:t>
+            </a:r>
+          </a:p>
+        </p:txBody>
+      </p:sp>
+      <p:sp>
+        <p:nvSpPr>
+          <p:cNvPr id="29" name="Rectangle 28"/>
           <p:cNvSpPr/>
           <p:nvPr/>
         </p:nvSpPr>
         <p:spPr>
           <a:xfrm>
-            <a:off x="0" y="6473952"/>
-            <a:ext cx="12188952" cy="384048"/>
+            <a:off x="457200" y="5029200"/>
+            <a:ext cx="11247120" cy="914400"/>
           </a:xfrm>
           <a:prstGeom prst="rect">
             <a:avLst/>
@@ -10533,7 +10611,85 @@
       </p:sp>
       <p:sp>
         <p:nvSpPr>
-          <p:cNvPr id="28" name="TextBox 27"/>
+          <p:cNvPr id="30" name="TextBox 29"/>
+          <p:cNvSpPr txBox="1"/>
+          <p:nvPr/>
+        </p:nvSpPr>
+        <p:spPr>
+          <a:xfrm>
+            <a:off x="640080" y="5120640"/>
+            <a:ext cx="10972800" cy="731520"/>
+          </a:xfrm>
+          <a:prstGeom prst="rect">
+            <a:avLst/>
+          </a:prstGeom>
+          <a:noFill/>
+        </p:spPr>
+        <p:txBody>
+          <a:bodyPr wrap="square">
+            <a:spAutoFit/>
+          </a:bodyPr>
+          <a:lstStyle/>
+          <a:p>
+            <a:pPr algn="ctr"/>
+            <a:r>
+              <a:rPr sz="2000" b="1">
+                <a:solidFill>
+                  <a:srgbClr val="000000"/>
+                </a:solidFill>
+                <a:latin typeface="Calibri"/>
+              </a:rPr>
+              <a:t>Fragen?   Ich kann Claude Code direkt hier im Terminal demonstrieren.</a:t>
+            </a:r>
+          </a:p>
+        </p:txBody>
+      </p:sp>
+      <p:sp>
+        <p:nvSpPr>
+          <p:cNvPr id="31" name="Rectangle 30"/>
+          <p:cNvSpPr/>
+          <p:nvPr/>
+        </p:nvSpPr>
+        <p:spPr>
+          <a:xfrm>
+            <a:off x="0" y="6473952"/>
+            <a:ext cx="12188952" cy="384048"/>
+          </a:xfrm>
+          <a:prstGeom prst="rect">
+            <a:avLst/>
+          </a:prstGeom>
+          <a:solidFill>
+            <a:srgbClr val="FFE600"/>
+          </a:solidFill>
+          <a:ln>
+            <a:noFill/>
+          </a:ln>
+        </p:spPr>
+        <p:style>
+          <a:lnRef idx="1">
+            <a:schemeClr val="accent1"/>
+          </a:lnRef>
+          <a:fillRef idx="3">
+            <a:schemeClr val="accent1"/>
+          </a:fillRef>
+          <a:effectRef idx="2">
+            <a:schemeClr val="accent1"/>
+          </a:effectRef>
+          <a:fontRef idx="minor">
+            <a:schemeClr val="lt1"/>
+          </a:fontRef>
+        </p:style>
+        <p:txBody>
+          <a:bodyPr rtlCol="0" anchor="ctr"/>
+          <a:lstStyle/>
+          <a:p>
+            <a:pPr algn="ctr"/>
+          </a:p>
+        </p:txBody>
+      </p:sp>
+      <p:sp>
+        <p:nvSpPr>
+          <p:cNvPr id="32" name="TextBox 31"/>
           <p:cNvSpPr txBox="1"/>
           <p:nvPr/>
         </p:nvSpPr>
@@ -10568,7 +10724,7 @@
       </p:sp>
       <p:sp>
         <p:nvSpPr>
-          <p:cNvPr id="29" name="TextBox 28"/>
+          <p:cNvPr id="33" name="TextBox 32"/>
           <p:cNvSpPr txBox="1"/>
           <p:nvPr/>
         </p:nvSpPr>

</xml_diff>

<commit_message>
Umlaute in Präsentation korrigiert (ä, ö, ü)
</commit_message>
<xml_diff>
--- a/Claude_Code_Pitch.pptx
+++ b/Claude_Code_Pitch.pptx
@@ -4953,7 +4953,7 @@
                 </a:solidFill>
                 <a:latin typeface="Calibri"/>
               </a:rPr>
-              <a:t>VS Code (taeglicher Einsatz) + JetBrains</a:t>
+              <a:t>VS Code (täglicher Einsatz) + JetBrains</a:t>
             </a:r>
           </a:p>
         </p:txBody>
@@ -5066,7 +5066,7 @@
                 </a:solidFill>
                 <a:latin typeface="Calibri"/>
               </a:rPr>
-              <a:t>Laeuft via Anthropic API</a:t>
+              <a:t>Läuft via Anthropic API</a:t>
             </a:r>
           </a:p>
         </p:txBody>
@@ -6354,7 +6354,7 @@
                 </a:solidFill>
                 <a:latin typeface="Calibri"/>
               </a:rPr>
-              <a:t>Proprietaere Modelle, kein Ollama / LM Studio</a:t>
+              <a:t>Proprietäre Modelle, kein Ollama / LM Studio</a:t>
             </a:r>
           </a:p>
         </p:txBody>
@@ -7545,7 +7545,7 @@
                 </a:solidFill>
                 <a:latin typeface="Calibri"/>
               </a:rPr>
-              <a:t>Kein dediziertes Student-Pricing. API Pay-per-use ist fuer Studierende am guenstigsten.</a:t>
+              <a:t>Kein dediziertes Student-Pricing. API Pay-per-use ist für Studierende am günstigsten.</a:t>
             </a:r>
           </a:p>
         </p:txBody>
@@ -8459,7 +8459,7 @@
                 </a:solidFill>
                 <a:latin typeface="Calibri"/>
               </a:rPr>
-              <a:t>Fazit: Claude Code ist kein Open-Source-Projekt, aber CLI-Client und SDKs sind frei zugaenglich.</a:t>
+              <a:t>Fazit: Claude Code ist kein Open-Source-Projekt, aber CLI-Client und SDKs sind frei zugänglich.</a:t>
             </a:r>
           </a:p>
         </p:txBody>
@@ -9781,7 +9781,7 @@
                 </a:solidFill>
                 <a:latin typeface="Calibri"/>
               </a:rPr>
-              <a:t>Plant und fuehrt mehrstufige Software-Tasks eigenstaendig aus</a:t>
+              <a:t>Plant und führt mehrstufige Software-Tasks eigenständig aus</a:t>
             </a:r>
           </a:p>
         </p:txBody>
@@ -10249,7 +10249,7 @@
                 </a:solidFill>
                 <a:latin typeface="Calibri"/>
               </a:rPr>
-              <a:t>API Pay-per-use ideal fuer Studierende (ab ca. $5)</a:t>
+              <a:t>API Pay-per-use ideal für Studierende (ab ca. $5)</a:t>
             </a:r>
           </a:p>
         </p:txBody>
@@ -10405,7 +10405,7 @@
                 </a:solidFill>
                 <a:latin typeface="Calibri"/>
               </a:rPr>
-              <a:t>Nicht vollstaendig: CLI frei zugaenglich, Modelle proprietaer</a:t>
+              <a:t>Nicht vollständig: CLI frei zugänglich, Modelle proprietär</a:t>
             </a:r>
           </a:p>
         </p:txBody>

</xml_diff>